<commit_message>
Embed charts directly into PPT presentation
</commit_message>
<xml_diff>
--- a/VOIS_Project_PPT.pptx
+++ b/VOIS_Project_PPT.pptx
@@ -10997,45 +10997,30 @@
           </a:p>
         </p:txBody>
       </p:sp>
-      <p:sp>
-        <p:nvSpPr>
-          <p:cNvPr id="33" name="TextBox 32"/>
-          <p:cNvSpPr txBox="1"/>
+      <p:pic>
+        <p:nvPicPr>
+          <p:cNvPr id="33" name="Picture 32" descr="12_correlation_heatmap.png"/>
+          <p:cNvPicPr>
+            <a:picLocks noChangeAspect="1"/>
+          </p:cNvPicPr>
           <p:nvPr/>
-        </p:nvSpPr>
+        </p:nvPicPr>
+        <p:blipFill>
+          <a:blip r:embed="rId3"/>
+          <a:stretch>
+            <a:fillRect/>
+          </a:stretch>
+        </p:blipFill>
         <p:spPr>
           <a:xfrm>
-            <a:off x="4754880" y="1097280"/>
-            <a:ext cx="4114800" cy="3200400"/>
+            <a:off x="6035040" y="1005840"/>
+            <a:ext cx="5303520" cy="4896798"/>
           </a:xfrm>
           <a:prstGeom prst="rect">
             <a:avLst/>
           </a:prstGeom>
-          <a:noFill/>
         </p:spPr>
-        <p:txBody>
-          <a:bodyPr wrap="square">
-            <a:spAutoFit/>
-          </a:bodyPr>
-          <a:lstStyle/>
-          <a:p>
-            <a:pPr algn="ctr">
-              <a:defRPr sz="1100" b="0">
-                <a:solidFill>
-                  <a:srgbClr val="999999"/>
-                </a:solidFill>
-              </a:defRPr>
-            </a:pPr>
-            <a:r>
-              <a:t>[INSERT CHART: Correlation Heatmap]</a:t>
-            </a:r>
-            <a:br/>
-            <a:r>
-              <a:t>(charts/12_correlation_heatmap.png)</a:t>
-            </a:r>
-          </a:p>
-        </p:txBody>
-      </p:sp>
+      </p:pic>
     </p:spTree>
     <p:extLst>
       <p:ext uri="{BB962C8B-B14F-4D97-AF65-F5344CB8AC3E}">
@@ -15659,84 +15644,54 @@
           </a:p>
         </p:txBody>
       </p:sp>
-      <p:sp>
-        <p:nvSpPr>
-          <p:cNvPr id="33" name="TextBox 32"/>
-          <p:cNvSpPr txBox="1"/>
+      <p:pic>
+        <p:nvPicPr>
+          <p:cNvPr id="33" name="Picture 32" descr="01_avg_yield_by_season.png"/>
+          <p:cNvPicPr>
+            <a:picLocks noChangeAspect="1"/>
+          </p:cNvPicPr>
           <p:nvPr/>
-        </p:nvSpPr>
+        </p:nvPicPr>
+        <p:blipFill>
+          <a:blip r:embed="rId3"/>
+          <a:stretch>
+            <a:fillRect/>
+          </a:stretch>
+        </p:blipFill>
         <p:spPr>
           <a:xfrm>
-            <a:off x="274320" y="2926080"/>
-            <a:ext cx="4114800" cy="1828800"/>
+            <a:off x="731520" y="2743200"/>
+            <a:ext cx="5029200" cy="3104761"/>
           </a:xfrm>
           <a:prstGeom prst="rect">
             <a:avLst/>
           </a:prstGeom>
-          <a:noFill/>
         </p:spPr>
-        <p:txBody>
-          <a:bodyPr wrap="square">
-            <a:spAutoFit/>
-          </a:bodyPr>
-          <a:lstStyle/>
-          <a:p>
-            <a:pPr algn="ctr">
-              <a:defRPr sz="1100" b="0">
-                <a:solidFill>
-                  <a:srgbClr val="999999"/>
-                </a:solidFill>
-              </a:defRPr>
-            </a:pPr>
-            <a:r>
-              <a:t>[INSERT CHART: Average Yield by Season]</a:t>
-            </a:r>
-            <a:br/>
-            <a:r>
-              <a:t>(charts/01_avg_yield_by_season.png)</a:t>
-            </a:r>
-          </a:p>
-        </p:txBody>
-      </p:sp>
-      <p:sp>
-        <p:nvSpPr>
-          <p:cNvPr id="34" name="TextBox 33"/>
-          <p:cNvSpPr txBox="1"/>
+      </p:pic>
+      <p:pic>
+        <p:nvPicPr>
+          <p:cNvPr id="34" name="Picture 33" descr="02_avg_profit_by_season.png"/>
+          <p:cNvPicPr>
+            <a:picLocks noChangeAspect="1"/>
+          </p:cNvPicPr>
           <p:nvPr/>
-        </p:nvSpPr>
+        </p:nvPicPr>
+        <p:blipFill>
+          <a:blip r:embed="rId4"/>
+          <a:stretch>
+            <a:fillRect/>
+          </a:stretch>
+        </p:blipFill>
         <p:spPr>
           <a:xfrm>
-            <a:off x="4754880" y="2926080"/>
-            <a:ext cx="4114800" cy="1828800"/>
+            <a:off x="6217920" y="2743200"/>
+            <a:ext cx="5029200" cy="3099490"/>
           </a:xfrm>
           <a:prstGeom prst="rect">
             <a:avLst/>
           </a:prstGeom>
-          <a:noFill/>
         </p:spPr>
-        <p:txBody>
-          <a:bodyPr wrap="square">
-            <a:spAutoFit/>
-          </a:bodyPr>
-          <a:lstStyle/>
-          <a:p>
-            <a:pPr algn="ctr">
-              <a:defRPr sz="1100" b="0">
-                <a:solidFill>
-                  <a:srgbClr val="999999"/>
-                </a:solidFill>
-              </a:defRPr>
-            </a:pPr>
-            <a:r>
-              <a:t>[INSERT CHART: Average Profit by Season]</a:t>
-            </a:r>
-            <a:br/>
-            <a:r>
-              <a:t>(charts/02_avg_profit_by_season.png)</a:t>
-            </a:r>
-          </a:p>
-        </p:txBody>
-      </p:sp>
+      </p:pic>
     </p:spTree>
     <p:extLst>
       <p:ext uri="{BB962C8B-B14F-4D97-AF65-F5344CB8AC3E}">
@@ -16323,84 +16278,54 @@
           </a:p>
         </p:txBody>
       </p:sp>
-      <p:sp>
-        <p:nvSpPr>
-          <p:cNvPr id="33" name="TextBox 32"/>
-          <p:cNvSpPr txBox="1"/>
+      <p:pic>
+        <p:nvPicPr>
+          <p:cNvPr id="33" name="Picture 32" descr="03_total_production_by_season.png"/>
+          <p:cNvPicPr>
+            <a:picLocks noChangeAspect="1"/>
+          </p:cNvPicPr>
           <p:nvPr/>
-        </p:nvSpPr>
+        </p:nvPicPr>
+        <p:blipFill>
+          <a:blip r:embed="rId3"/>
+          <a:stretch>
+            <a:fillRect/>
+          </a:stretch>
+        </p:blipFill>
         <p:spPr>
           <a:xfrm>
-            <a:off x="274320" y="2560320"/>
-            <a:ext cx="4114800" cy="2286000"/>
+            <a:off x="731520" y="2468880"/>
+            <a:ext cx="5029200" cy="3099490"/>
           </a:xfrm>
           <a:prstGeom prst="rect">
             <a:avLst/>
           </a:prstGeom>
-          <a:noFill/>
         </p:spPr>
-        <p:txBody>
-          <a:bodyPr wrap="square">
-            <a:spAutoFit/>
-          </a:bodyPr>
-          <a:lstStyle/>
-          <a:p>
-            <a:pPr algn="ctr">
-              <a:defRPr sz="1100" b="0">
-                <a:solidFill>
-                  <a:srgbClr val="999999"/>
-                </a:solidFill>
-              </a:defRPr>
-            </a:pPr>
-            <a:r>
-              <a:t>[INSERT CHART: Total Production by Season]</a:t>
-            </a:r>
-            <a:br/>
-            <a:r>
-              <a:t>(charts/03_total_production_by_season.png)</a:t>
-            </a:r>
-          </a:p>
-        </p:txBody>
-      </p:sp>
-      <p:sp>
-        <p:nvSpPr>
-          <p:cNvPr id="34" name="TextBox 33"/>
-          <p:cNvSpPr txBox="1"/>
+      </p:pic>
+      <p:pic>
+        <p:nvPicPr>
+          <p:cNvPr id="34" name="Picture 33" descr="09_crop_wise_avg_yield.png"/>
+          <p:cNvPicPr>
+            <a:picLocks noChangeAspect="1"/>
+          </p:cNvPicPr>
           <p:nvPr/>
-        </p:nvSpPr>
+        </p:nvPicPr>
+        <p:blipFill>
+          <a:blip r:embed="rId4"/>
+          <a:stretch>
+            <a:fillRect/>
+          </a:stretch>
+        </p:blipFill>
         <p:spPr>
           <a:xfrm>
-            <a:off x="4754880" y="2560320"/>
-            <a:ext cx="4114800" cy="2286000"/>
+            <a:off x="6217920" y="2468880"/>
+            <a:ext cx="5029200" cy="2992921"/>
           </a:xfrm>
           <a:prstGeom prst="rect">
             <a:avLst/>
           </a:prstGeom>
-          <a:noFill/>
         </p:spPr>
-        <p:txBody>
-          <a:bodyPr wrap="square">
-            <a:spAutoFit/>
-          </a:bodyPr>
-          <a:lstStyle/>
-          <a:p>
-            <a:pPr algn="ctr">
-              <a:defRPr sz="1100" b="0">
-                <a:solidFill>
-                  <a:srgbClr val="999999"/>
-                </a:solidFill>
-              </a:defRPr>
-            </a:pPr>
-            <a:r>
-              <a:t>[INSERT CHART: Crop-wise Average Yield]</a:t>
-            </a:r>
-            <a:br/>
-            <a:r>
-              <a:t>(charts/09_crop_wise_avg_yield.png)</a:t>
-            </a:r>
-          </a:p>
-        </p:txBody>
-      </p:sp>
+      </p:pic>
     </p:spTree>
     <p:extLst>
       <p:ext uri="{BB962C8B-B14F-4D97-AF65-F5344CB8AC3E}">
@@ -16988,84 +16913,54 @@
           </a:p>
         </p:txBody>
       </p:sp>
-      <p:sp>
-        <p:nvSpPr>
-          <p:cNvPr id="33" name="TextBox 32"/>
-          <p:cNvSpPr txBox="1"/>
+      <p:pic>
+        <p:nvPicPr>
+          <p:cNvPr id="33" name="Picture 32" descr="04_rainfall_vs_yield.png"/>
+          <p:cNvPicPr>
+            <a:picLocks noChangeAspect="1"/>
+          </p:cNvPicPr>
           <p:nvPr/>
-        </p:nvSpPr>
+        </p:nvPicPr>
+        <p:blipFill>
+          <a:blip r:embed="rId3"/>
+          <a:stretch>
+            <a:fillRect/>
+          </a:stretch>
+        </p:blipFill>
         <p:spPr>
           <a:xfrm>
-            <a:off x="274320" y="2560320"/>
-            <a:ext cx="4114800" cy="2286000"/>
+            <a:off x="731520" y="2468880"/>
+            <a:ext cx="5029200" cy="2982789"/>
           </a:xfrm>
           <a:prstGeom prst="rect">
             <a:avLst/>
           </a:prstGeom>
-          <a:noFill/>
         </p:spPr>
-        <p:txBody>
-          <a:bodyPr wrap="square">
-            <a:spAutoFit/>
-          </a:bodyPr>
-          <a:lstStyle/>
-          <a:p>
-            <a:pPr algn="ctr">
-              <a:defRPr sz="1100" b="0">
-                <a:solidFill>
-                  <a:srgbClr val="999999"/>
-                </a:solidFill>
-              </a:defRPr>
-            </a:pPr>
-            <a:r>
-              <a:t>[INSERT CHART: Rainfall vs Yield]</a:t>
-            </a:r>
-            <a:br/>
-            <a:r>
-              <a:t>(charts/04_rainfall_vs_yield.png)</a:t>
-            </a:r>
-          </a:p>
-        </p:txBody>
-      </p:sp>
-      <p:sp>
-        <p:nvSpPr>
-          <p:cNvPr id="34" name="TextBox 33"/>
-          <p:cNvSpPr txBox="1"/>
+      </p:pic>
+      <p:pic>
+        <p:nvPicPr>
+          <p:cNvPr id="34" name="Picture 33" descr="08_disease_risk_by_season.png"/>
+          <p:cNvPicPr>
+            <a:picLocks noChangeAspect="1"/>
+          </p:cNvPicPr>
           <p:nvPr/>
-        </p:nvSpPr>
+        </p:nvPicPr>
+        <p:blipFill>
+          <a:blip r:embed="rId4"/>
+          <a:stretch>
+            <a:fillRect/>
+          </a:stretch>
+        </p:blipFill>
         <p:spPr>
           <a:xfrm>
-            <a:off x="4754880" y="2560320"/>
-            <a:ext cx="4114800" cy="2286000"/>
+            <a:off x="6217920" y="2468880"/>
+            <a:ext cx="5029200" cy="3102123"/>
           </a:xfrm>
           <a:prstGeom prst="rect">
             <a:avLst/>
           </a:prstGeom>
-          <a:noFill/>
         </p:spPr>
-        <p:txBody>
-          <a:bodyPr wrap="square">
-            <a:spAutoFit/>
-          </a:bodyPr>
-          <a:lstStyle/>
-          <a:p>
-            <a:pPr algn="ctr">
-              <a:defRPr sz="1100" b="0">
-                <a:solidFill>
-                  <a:srgbClr val="999999"/>
-                </a:solidFill>
-              </a:defRPr>
-            </a:pPr>
-            <a:r>
-              <a:t>[INSERT CHART: Disease/Pest Risk by Season]</a:t>
-            </a:r>
-            <a:br/>
-            <a:r>
-              <a:t>(charts/08_disease_risk_by_season.png)</a:t>
-            </a:r>
-          </a:p>
-        </p:txBody>
-      </p:sp>
+      </p:pic>
     </p:spTree>
     <p:extLst>
       <p:ext uri="{BB962C8B-B14F-4D97-AF65-F5344CB8AC3E}">
@@ -17653,84 +17548,54 @@
           </a:p>
         </p:txBody>
       </p:sp>
-      <p:sp>
-        <p:nvSpPr>
-          <p:cNvPr id="33" name="TextBox 32"/>
-          <p:cNvSpPr txBox="1"/>
+      <p:pic>
+        <p:nvPicPr>
+          <p:cNvPr id="33" name="Picture 32" descr="10_irrigation_vs_yield.png"/>
+          <p:cNvPicPr>
+            <a:picLocks noChangeAspect="1"/>
+          </p:cNvPicPr>
           <p:nvPr/>
-        </p:nvSpPr>
+        </p:nvPicPr>
+        <p:blipFill>
+          <a:blip r:embed="rId3"/>
+          <a:stretch>
+            <a:fillRect/>
+          </a:stretch>
+        </p:blipFill>
         <p:spPr>
           <a:xfrm>
-            <a:off x="274320" y="2560320"/>
-            <a:ext cx="4114800" cy="2286000"/>
+            <a:off x="731520" y="2468880"/>
+            <a:ext cx="5029200" cy="3104761"/>
           </a:xfrm>
           <a:prstGeom prst="rect">
             <a:avLst/>
           </a:prstGeom>
-          <a:noFill/>
         </p:spPr>
-        <p:txBody>
-          <a:bodyPr wrap="square">
-            <a:spAutoFit/>
-          </a:bodyPr>
-          <a:lstStyle/>
-          <a:p>
-            <a:pPr algn="ctr">
-              <a:defRPr sz="1100" b="0">
-                <a:solidFill>
-                  <a:srgbClr val="999999"/>
-                </a:solidFill>
-              </a:defRPr>
-            </a:pPr>
-            <a:r>
-              <a:t>[INSERT CHART: Irrigation Method vs Yield]</a:t>
-            </a:r>
-            <a:br/>
-            <a:r>
-              <a:t>(charts/10_irrigation_vs_yield.png)</a:t>
-            </a:r>
-          </a:p>
-        </p:txBody>
-      </p:sp>
-      <p:sp>
-        <p:nvSpPr>
-          <p:cNvPr id="34" name="TextBox 33"/>
-          <p:cNvSpPr txBox="1"/>
+      </p:pic>
+      <p:pic>
+        <p:nvPicPr>
+          <p:cNvPr id="34" name="Picture 33" descr="11_irrigation_vs_water_efficiency.png"/>
+          <p:cNvPicPr>
+            <a:picLocks noChangeAspect="1"/>
+          </p:cNvPicPr>
           <p:nvPr/>
-        </p:nvSpPr>
+        </p:nvPicPr>
+        <p:blipFill>
+          <a:blip r:embed="rId4"/>
+          <a:stretch>
+            <a:fillRect/>
+          </a:stretch>
+        </p:blipFill>
         <p:spPr>
           <a:xfrm>
-            <a:off x="4754880" y="2560320"/>
-            <a:ext cx="4114800" cy="2286000"/>
+            <a:off x="6217920" y="2468880"/>
+            <a:ext cx="5029200" cy="3104761"/>
           </a:xfrm>
           <a:prstGeom prst="rect">
             <a:avLst/>
           </a:prstGeom>
-          <a:noFill/>
         </p:spPr>
-        <p:txBody>
-          <a:bodyPr wrap="square">
-            <a:spAutoFit/>
-          </a:bodyPr>
-          <a:lstStyle/>
-          <a:p>
-            <a:pPr algn="ctr">
-              <a:defRPr sz="1100" b="0">
-                <a:solidFill>
-                  <a:srgbClr val="999999"/>
-                </a:solidFill>
-              </a:defRPr>
-            </a:pPr>
-            <a:r>
-              <a:t>[INSERT CHART: Irrigation vs Water Efficiency]</a:t>
-            </a:r>
-            <a:br/>
-            <a:r>
-              <a:t>(charts/11_irrigation_vs_water_efficiency.png)</a:t>
-            </a:r>
-          </a:p>
-        </p:txBody>
-      </p:sp>
+      </p:pic>
     </p:spTree>
     <p:extLst>
       <p:ext uri="{BB962C8B-B14F-4D97-AF65-F5344CB8AC3E}">

</xml_diff>

<commit_message>
Add course certificate, AICTE STU ID, and complete final deliverables in PPT
</commit_message>
<xml_diff>
--- a/VOIS_Project_PPT.pptx
+++ b/VOIS_Project_PPT.pptx
@@ -10155,8 +10155,8 @@
         </p:nvSpPr>
         <p:spPr>
           <a:xfrm>
-            <a:off x="914400" y="2651760"/>
-            <a:ext cx="7315200" cy="457200"/>
+            <a:off x="914400" y="2423160"/>
+            <a:ext cx="7315200" cy="411480"/>
           </a:xfrm>
           <a:prstGeom prst="rect">
             <a:avLst/>
@@ -10190,8 +10190,8 @@
         </p:nvSpPr>
         <p:spPr>
           <a:xfrm>
-            <a:off x="914400" y="3200400"/>
-            <a:ext cx="7315200" cy="457200"/>
+            <a:off x="914400" y="2926080"/>
+            <a:ext cx="7315200" cy="411480"/>
           </a:xfrm>
           <a:prstGeom prst="rect">
             <a:avLst/>
@@ -10248,6 +10248,41 @@
             </a:pPr>
             <a:r>
               <a:t>Data Analytics Internship — Seasonal Agriculture Performance Analysis</a:t>
+            </a:r>
+          </a:p>
+        </p:txBody>
+      </p:sp>
+      <p:sp>
+        <p:nvSpPr>
+          <p:cNvPr id="44" name="TextBox 43"/>
+          <p:cNvSpPr txBox="1"/>
+          <p:nvPr/>
+        </p:nvSpPr>
+        <p:spPr>
+          <a:xfrm>
+            <a:off x="914400" y="3429000"/>
+            <a:ext cx="7315200" cy="411480"/>
+          </a:xfrm>
+          <a:prstGeom prst="rect">
+            <a:avLst/>
+          </a:prstGeom>
+          <a:noFill/>
+        </p:spPr>
+        <p:txBody>
+          <a:bodyPr wrap="square">
+            <a:spAutoFit/>
+          </a:bodyPr>
+          <a:lstStyle/>
+          <a:p>
+            <a:pPr>
+              <a:defRPr sz="1600" b="1">
+                <a:solidFill>
+                  <a:srgbClr val="FFFFFF"/>
+                </a:solidFill>
+              </a:defRPr>
+            </a:pPr>
+            <a:r>
+              <a:t>AICTE STU ID: STU6a252b77248381780820855</a:t>
             </a:r>
           </a:p>
         </p:txBody>
@@ -12154,31 +12189,63 @@
           </a:bodyPr>
           <a:lstStyle/>
           <a:p>
-            <a:pPr algn="ctr">
-              <a:defRPr sz="1200" b="0">
+            <a:pPr>
+              <a:defRPr sz="1400">
                 <a:solidFill>
-                  <a:srgbClr val="777777"/>
+                  <a:srgbClr val="505050"/>
                 </a:solidFill>
               </a:defRPr>
             </a:pPr>
             <a:r>
-              <a:t>Repository should contain:</a:t>
-            </a:r>
-            <a:br/>
-            <a:r>
-              <a:t>• Jupyter Notebook</a:t>
-            </a:r>
-            <a:br/>
-            <a:r>
-              <a:t>• Dataset (CSV)</a:t>
-            </a:r>
-            <a:br/>
-            <a:r>
-              <a:t>• Charts folder</a:t>
-            </a:r>
-            <a:br/>
-            <a:r>
-              <a:t>• README.md</a:t>
+              <a:t>Repository Contents:</a:t>
+            </a:r>
+          </a:p>
+          <a:p>
+            <a:pPr>
+              <a:defRPr sz="1400">
+                <a:solidFill>
+                  <a:srgbClr val="505050"/>
+                </a:solidFill>
+              </a:defRPr>
+            </a:pPr>
+            <a:r>
+              <a:t>• Jupyter Notebook (.ipynb) with complete analysis</a:t>
+            </a:r>
+          </a:p>
+          <a:p>
+            <a:pPr>
+              <a:defRPr sz="1400">
+                <a:solidFill>
+                  <a:srgbClr val="505050"/>
+                </a:solidFill>
+              </a:defRPr>
+            </a:pPr>
+            <a:r>
+              <a:t>• Dataset (CSV) — 4,000 records × 28 features</a:t>
+            </a:r>
+          </a:p>
+          <a:p>
+            <a:pPr>
+              <a:defRPr sz="1400">
+                <a:solidFill>
+                  <a:srgbClr val="505050"/>
+                </a:solidFill>
+              </a:defRPr>
+            </a:pPr>
+            <a:r>
+              <a:t>• 12 High-Resolution Visualizations (charts/)</a:t>
+            </a:r>
+          </a:p>
+          <a:p>
+            <a:pPr>
+              <a:defRPr sz="1400">
+                <a:solidFill>
+                  <a:srgbClr val="505050"/>
+                </a:solidFill>
+              </a:defRPr>
+            </a:pPr>
+            <a:r>
+              <a:t>• Complete Documentation &amp; Verification Reports</a:t>
             </a:r>
           </a:p>
         </p:txBody>
@@ -12600,15 +12667,8 @@
           <a:bodyPr rtlCol="0" anchor="ctr" wrap="square" lIns="457200"/>
           <a:lstStyle/>
           <a:p>
-            <a:pPr algn="l">
-              <a:defRPr sz="2400" b="1">
-                <a:solidFill>
-                  <a:srgbClr val="FFFFFF"/>
-                </a:solidFill>
-              </a:defRPr>
-            </a:pPr>
-            <a:r>
-              <a:t>  VOIS Course Completion Certificate</a:t>
+            <a:r>
+              <a:t>  VOIS Course Completion Certificate — Data Visualization</a:t>
             </a:r>
           </a:p>
         </p:txBody>
@@ -12621,8 +12681,8 @@
         </p:nvSpPr>
         <p:spPr>
           <a:xfrm>
-            <a:off x="914400" y="1188720"/>
-            <a:ext cx="7315200" cy="457200"/>
+            <a:off x="914400" y="822960"/>
+            <a:ext cx="10360152" cy="365760"/>
           </a:xfrm>
           <a:prstGeom prst="rect">
             <a:avLst/>
@@ -12635,54 +12695,43 @@
           </a:bodyPr>
           <a:lstStyle/>
           <a:p>
-            <a:pPr algn="ctr">
-              <a:defRPr sz="1400" b="0">
+            <a:pPr>
+              <a:defRPr sz="1400" b="1">
                 <a:solidFill>
-                  <a:srgbClr val="555555"/>
+                  <a:srgbClr val="323232"/>
                 </a:solidFill>
               </a:defRPr>
             </a:pPr>
             <a:r>
-              <a:t>Course: Data Analytics</a:t>
+              <a:t>Course: Data Visualization  |  Certificate ID: VFLMS26_163451  |  Issued: September 6, 2026</a:t>
             </a:r>
           </a:p>
         </p:txBody>
       </p:sp>
-      <p:sp>
-        <p:nvSpPr>
-          <p:cNvPr id="26" name="TextBox 25"/>
-          <p:cNvSpPr txBox="1"/>
+      <p:pic>
+        <p:nvPicPr>
+          <p:cNvPr id="26" name="Picture 25" descr="certificate.png"/>
+          <p:cNvPicPr>
+            <a:picLocks noChangeAspect="1"/>
+          </p:cNvPicPr>
           <p:nvPr/>
-        </p:nvSpPr>
+        </p:nvPicPr>
+        <p:blipFill>
+          <a:blip r:embed="rId3"/>
+          <a:stretch>
+            <a:fillRect/>
+          </a:stretch>
+        </p:blipFill>
         <p:spPr>
           <a:xfrm>
-            <a:off x="914400" y="2011680"/>
-            <a:ext cx="7315200" cy="2743200"/>
+            <a:off x="2475845" y="1280160"/>
+            <a:ext cx="7240308" cy="5120640"/>
           </a:xfrm>
           <a:prstGeom prst="rect">
             <a:avLst/>
           </a:prstGeom>
-          <a:noFill/>
         </p:spPr>
-        <p:txBody>
-          <a:bodyPr wrap="square">
-            <a:spAutoFit/>
-          </a:bodyPr>
-          <a:lstStyle/>
-          <a:p>
-            <a:pPr algn="ctr">
-              <a:defRPr sz="1600" b="1">
-                <a:solidFill>
-                  <a:srgbClr val="999999"/>
-                </a:solidFill>
-              </a:defRPr>
-            </a:pPr>
-            <a:r>
-              <a:t>[INSERT YOUR VOIS COURSE COMPLETION CERTIFICATE SCREENSHOT HERE]</a:t>
-            </a:r>
-          </a:p>
-        </p:txBody>
-      </p:sp>
+      </p:pic>
     </p:spTree>
     <p:extLst>
       <p:ext uri="{BB962C8B-B14F-4D97-AF65-F5344CB8AC3E}">

</xml_diff>